<commit_message>
Fix overlapping/cropped text in generated PPTX slides
Root cause: text boxes were created without word_wrap or auto_size
settings, so PowerPoint/LibreOffice expanded them to fit text on a
single line instead of respecting the specified width -- causing long
text (e.g. the cover-slide subtitle) to overflow into neighboring
shapes, and the variance-insights KPMG logo to drift into the title.

- deck-refresh/tools/generate_sample_files.py: word_wrap=True,
  auto_size=NONE on all text boxes; regenerated sample files
- variance-insights/app.py: same fix on the slide-generation header;
  explicit left-alignment on the KPMG logo so it can't center across
  the full-width bar and collide with the title
- Regenerated screenshots in both tools from the fixed output
- Verified via real LibreOffice rendering + programmatic text-position
  extraction (no off-slide or overlapping text spans), including a
  stress test with a deliberately oversized title/subtitle
</commit_message>
<xml_diff>
--- a/deck-refresh/sample_files/kpmg_advisory_q3_original.pptx
+++ b/deck-refresh/sample_files/kpmg_advisory_q3_original.pptx
@@ -4652,8 +4652,8 @@
           <a:noFill/>
         </p:spPr>
         <p:txBody>
-          <a:bodyPr wrap="none" lIns="54864" rIns="54864" tIns="54864" bIns="54864" anchor="ctr">
-            <a:spAutoFit/>
+          <a:bodyPr wrap="square" lIns="54864" rIns="54864" tIns="54864" bIns="54864" anchor="ctr">
+            <a:noAutofit/>
           </a:bodyPr>
           <a:lstStyle/>
           <a:p>
@@ -4688,8 +4688,8 @@
           <a:noFill/>
         </p:spPr>
         <p:txBody>
-          <a:bodyPr wrap="none" lIns="54864" rIns="54864" tIns="54864" bIns="54864" anchor="ctr">
-            <a:spAutoFit/>
+          <a:bodyPr wrap="square" lIns="54864" rIns="54864" tIns="54864" bIns="54864" anchor="ctr">
+            <a:noAutofit/>
           </a:bodyPr>
           <a:lstStyle/>
           <a:p>
@@ -4724,8 +4724,8 @@
           <a:noFill/>
         </p:spPr>
         <p:txBody>
-          <a:bodyPr wrap="none" lIns="54864" rIns="54864" tIns="54864" bIns="54864" anchor="ctr">
-            <a:spAutoFit/>
+          <a:bodyPr wrap="square" lIns="54864" rIns="54864" tIns="54864" bIns="54864" anchor="ctr">
+            <a:noAutofit/>
           </a:bodyPr>
           <a:lstStyle/>
           <a:p>
@@ -4803,8 +4803,8 @@
           <a:noFill/>
         </p:spPr>
         <p:txBody>
-          <a:bodyPr wrap="none" lIns="54864" rIns="54864" tIns="54864" bIns="54864" anchor="ctr">
-            <a:spAutoFit/>
+          <a:bodyPr wrap="square" lIns="54864" rIns="54864" tIns="54864" bIns="54864" anchor="ctr">
+            <a:noAutofit/>
           </a:bodyPr>
           <a:lstStyle/>
           <a:p>
@@ -4843,8 +4843,8 @@
           <a:noFill/>
         </p:spPr>
         <p:txBody>
-          <a:bodyPr wrap="none" lIns="54864" rIns="54864" tIns="54864" bIns="54864" anchor="ctr">
-            <a:spAutoFit/>
+          <a:bodyPr wrap="square" lIns="54864" rIns="54864" tIns="54864" bIns="54864" anchor="ctr">
+            <a:noAutofit/>
           </a:bodyPr>
           <a:lstStyle/>
           <a:p>
@@ -4897,8 +4897,8 @@
           <a:noFill/>
         </p:spPr>
         <p:txBody>
-          <a:bodyPr wrap="none" lIns="54864" rIns="54864" tIns="54864" bIns="54864" anchor="ctr">
-            <a:spAutoFit/>
+          <a:bodyPr wrap="square" lIns="54864" rIns="54864" tIns="54864" bIns="54864" anchor="ctr">
+            <a:noAutofit/>
           </a:bodyPr>
           <a:lstStyle/>
           <a:p>
@@ -4933,8 +4933,8 @@
           <a:noFill/>
         </p:spPr>
         <p:txBody>
-          <a:bodyPr wrap="none" lIns="54864" rIns="54864" tIns="54864" bIns="54864" anchor="ctr">
-            <a:spAutoFit/>
+          <a:bodyPr wrap="square" lIns="54864" rIns="54864" tIns="54864" bIns="54864" anchor="ctr">
+            <a:noAutofit/>
           </a:bodyPr>
           <a:lstStyle/>
           <a:p>
@@ -5034,7 +5034,9 @@
           </a:fontRef>
         </p:style>
         <p:txBody>
-          <a:bodyPr rtlCol="0" anchor="ctr" lIns="164592" rIns="109728" tIns="91440" bIns="73152"/>
+          <a:bodyPr rtlCol="0" anchor="ctr" wrap="square" lIns="164592" rIns="109728" tIns="91440" bIns="73152">
+            <a:noAutofit/>
+          </a:bodyPr>
           <a:lstStyle/>
           <a:p>
             <a:pPr algn="ctr">
@@ -5146,7 +5148,9 @@
           </a:fontRef>
         </p:style>
         <p:txBody>
-          <a:bodyPr rtlCol="0" anchor="ctr" lIns="164592" rIns="109728" tIns="91440" bIns="73152"/>
+          <a:bodyPr rtlCol="0" anchor="ctr" wrap="square" lIns="164592" rIns="109728" tIns="91440" bIns="73152">
+            <a:noAutofit/>
+          </a:bodyPr>
           <a:lstStyle/>
           <a:p>
             <a:pPr algn="ctr">
@@ -5258,7 +5262,9 @@
           </a:fontRef>
         </p:style>
         <p:txBody>
-          <a:bodyPr rtlCol="0" anchor="ctr" lIns="164592" rIns="109728" tIns="91440" bIns="73152"/>
+          <a:bodyPr rtlCol="0" anchor="ctr" wrap="square" lIns="164592" rIns="109728" tIns="91440" bIns="73152">
+            <a:noAutofit/>
+          </a:bodyPr>
           <a:lstStyle/>
           <a:p>
             <a:pPr algn="ctr">
@@ -5370,7 +5376,9 @@
           </a:fontRef>
         </p:style>
         <p:txBody>
-          <a:bodyPr rtlCol="0" anchor="ctr" lIns="164592" rIns="109728" tIns="91440" bIns="73152"/>
+          <a:bodyPr rtlCol="0" anchor="ctr" wrap="square" lIns="164592" rIns="109728" tIns="91440" bIns="73152">
+            <a:noAutofit/>
+          </a:bodyPr>
           <a:lstStyle/>
           <a:p>
             <a:pPr algn="ctr">
@@ -5482,7 +5490,9 @@
           </a:fontRef>
         </p:style>
         <p:txBody>
-          <a:bodyPr rtlCol="0" anchor="ctr" lIns="164592" rIns="109728" tIns="91440" bIns="73152"/>
+          <a:bodyPr rtlCol="0" anchor="ctr" wrap="square" lIns="164592" rIns="109728" tIns="91440" bIns="73152">
+            <a:noAutofit/>
+          </a:bodyPr>
           <a:lstStyle/>
           <a:p>
             <a:pPr algn="ctr">
@@ -5594,7 +5604,9 @@
           </a:fontRef>
         </p:style>
         <p:txBody>
-          <a:bodyPr rtlCol="0" anchor="ctr" lIns="164592" rIns="109728" tIns="91440" bIns="73152"/>
+          <a:bodyPr rtlCol="0" anchor="ctr" wrap="square" lIns="164592" rIns="109728" tIns="91440" bIns="73152">
+            <a:noAutofit/>
+          </a:bodyPr>
           <a:lstStyle/>
           <a:p>
             <a:pPr algn="ctr">
@@ -5684,8 +5696,8 @@
           <a:noFill/>
         </p:spPr>
         <p:txBody>
-          <a:bodyPr wrap="none" lIns="54864" rIns="54864" tIns="54864" bIns="54864" anchor="ctr">
-            <a:spAutoFit/>
+          <a:bodyPr wrap="square" lIns="54864" rIns="54864" tIns="54864" bIns="54864" anchor="ctr">
+            <a:noAutofit/>
           </a:bodyPr>
           <a:lstStyle/>
           <a:p>
@@ -5738,8 +5750,8 @@
           <a:noFill/>
         </p:spPr>
         <p:txBody>
-          <a:bodyPr wrap="none" lIns="54864" rIns="54864" tIns="54864" bIns="54864" anchor="ctr">
-            <a:spAutoFit/>
+          <a:bodyPr wrap="square" lIns="54864" rIns="54864" tIns="54864" bIns="54864" anchor="ctr">
+            <a:noAutofit/>
           </a:bodyPr>
           <a:lstStyle/>
           <a:p>
@@ -5774,8 +5786,8 @@
           <a:noFill/>
         </p:spPr>
         <p:txBody>
-          <a:bodyPr wrap="none" lIns="54864" rIns="54864" tIns="54864" bIns="54864" anchor="ctr">
-            <a:spAutoFit/>
+          <a:bodyPr wrap="square" lIns="54864" rIns="54864" tIns="54864" bIns="54864" anchor="ctr">
+            <a:noAutofit/>
           </a:bodyPr>
           <a:lstStyle/>
           <a:p>
@@ -6342,8 +6354,8 @@
           <a:noFill/>
         </p:spPr>
         <p:txBody>
-          <a:bodyPr wrap="none" lIns="54864" rIns="54864" tIns="54864" bIns="54864" anchor="ctr">
-            <a:spAutoFit/>
+          <a:bodyPr wrap="square" lIns="54864" rIns="54864" tIns="54864" bIns="54864" anchor="ctr">
+            <a:noAutofit/>
           </a:bodyPr>
           <a:lstStyle/>
           <a:p>
@@ -6396,8 +6408,8 @@
           <a:noFill/>
         </p:spPr>
         <p:txBody>
-          <a:bodyPr wrap="none" lIns="54864" rIns="54864" tIns="54864" bIns="54864" anchor="ctr">
-            <a:spAutoFit/>
+          <a:bodyPr wrap="square" lIns="54864" rIns="54864" tIns="54864" bIns="54864" anchor="ctr">
+            <a:noAutofit/>
           </a:bodyPr>
           <a:lstStyle/>
           <a:p>
@@ -6432,8 +6444,8 @@
           <a:noFill/>
         </p:spPr>
         <p:txBody>
-          <a:bodyPr wrap="none" lIns="54864" rIns="54864" tIns="54864" bIns="54864" anchor="ctr">
-            <a:spAutoFit/>
+          <a:bodyPr wrap="square" lIns="54864" rIns="54864" tIns="54864" bIns="54864" anchor="ctr">
+            <a:noAutofit/>
           </a:bodyPr>
           <a:lstStyle/>
           <a:p>
@@ -6926,8 +6938,8 @@
           <a:noFill/>
         </p:spPr>
         <p:txBody>
-          <a:bodyPr wrap="none" lIns="54864" rIns="54864" tIns="54864" bIns="54864" anchor="ctr">
-            <a:spAutoFit/>
+          <a:bodyPr wrap="square" lIns="54864" rIns="54864" tIns="54864" bIns="54864" anchor="ctr">
+            <a:noAutofit/>
           </a:bodyPr>
           <a:lstStyle/>
           <a:p>
@@ -6980,8 +6992,8 @@
           <a:noFill/>
         </p:spPr>
         <p:txBody>
-          <a:bodyPr wrap="none" lIns="54864" rIns="54864" tIns="54864" bIns="54864" anchor="ctr">
-            <a:spAutoFit/>
+          <a:bodyPr wrap="square" lIns="54864" rIns="54864" tIns="54864" bIns="54864" anchor="ctr">
+            <a:noAutofit/>
           </a:bodyPr>
           <a:lstStyle/>
           <a:p>
@@ -7016,8 +7028,8 @@
           <a:noFill/>
         </p:spPr>
         <p:txBody>
-          <a:bodyPr wrap="none" lIns="54864" rIns="54864" tIns="54864" bIns="54864" anchor="ctr">
-            <a:spAutoFit/>
+          <a:bodyPr wrap="square" lIns="54864" rIns="54864" tIns="54864" bIns="54864" anchor="ctr">
+            <a:noAutofit/>
           </a:bodyPr>
           <a:lstStyle/>
           <a:p>
@@ -7510,8 +7522,8 @@
           <a:noFill/>
         </p:spPr>
         <p:txBody>
-          <a:bodyPr wrap="none" lIns="54864" rIns="54864" tIns="54864" bIns="54864" anchor="ctr">
-            <a:spAutoFit/>
+          <a:bodyPr wrap="square" lIns="54864" rIns="54864" tIns="54864" bIns="54864" anchor="ctr">
+            <a:noAutofit/>
           </a:bodyPr>
           <a:lstStyle/>
           <a:p>
@@ -7564,8 +7576,8 @@
           <a:noFill/>
         </p:spPr>
         <p:txBody>
-          <a:bodyPr wrap="none" lIns="54864" rIns="54864" tIns="54864" bIns="54864" anchor="ctr">
-            <a:spAutoFit/>
+          <a:bodyPr wrap="square" lIns="54864" rIns="54864" tIns="54864" bIns="54864" anchor="ctr">
+            <a:noAutofit/>
           </a:bodyPr>
           <a:lstStyle/>
           <a:p>
@@ -7600,8 +7612,8 @@
           <a:noFill/>
         </p:spPr>
         <p:txBody>
-          <a:bodyPr wrap="none" lIns="54864" rIns="54864" tIns="54864" bIns="54864" anchor="ctr">
-            <a:spAutoFit/>
+          <a:bodyPr wrap="square" lIns="54864" rIns="54864" tIns="54864" bIns="54864" anchor="ctr">
+            <a:noAutofit/>
           </a:bodyPr>
           <a:lstStyle/>
           <a:p>
@@ -7701,7 +7713,9 @@
           </a:fontRef>
         </p:style>
         <p:txBody>
-          <a:bodyPr rtlCol="0" anchor="ctr" lIns="164592" rIns="109728" tIns="91440" bIns="73152"/>
+          <a:bodyPr rtlCol="0" anchor="ctr" wrap="square" lIns="164592" rIns="109728" tIns="91440" bIns="73152">
+            <a:noAutofit/>
+          </a:bodyPr>
           <a:lstStyle/>
           <a:p>
             <a:pPr algn="ctr">
@@ -7813,7 +7827,9 @@
           </a:fontRef>
         </p:style>
         <p:txBody>
-          <a:bodyPr rtlCol="0" anchor="ctr" lIns="164592" rIns="109728" tIns="91440" bIns="73152"/>
+          <a:bodyPr rtlCol="0" anchor="ctr" wrap="square" lIns="164592" rIns="109728" tIns="91440" bIns="73152">
+            <a:noAutofit/>
+          </a:bodyPr>
           <a:lstStyle/>
           <a:p>
             <a:pPr algn="ctr">
@@ -7925,7 +7941,9 @@
           </a:fontRef>
         </p:style>
         <p:txBody>
-          <a:bodyPr rtlCol="0" anchor="ctr" lIns="164592" rIns="109728" tIns="91440" bIns="73152"/>
+          <a:bodyPr rtlCol="0" anchor="ctr" wrap="square" lIns="164592" rIns="109728" tIns="91440" bIns="73152">
+            <a:noAutofit/>
+          </a:bodyPr>
           <a:lstStyle/>
           <a:p>
             <a:pPr algn="ctr">
@@ -8037,7 +8055,9 @@
           </a:fontRef>
         </p:style>
         <p:txBody>
-          <a:bodyPr rtlCol="0" anchor="ctr" lIns="164592" rIns="109728" tIns="91440" bIns="73152"/>
+          <a:bodyPr rtlCol="0" anchor="ctr" wrap="square" lIns="164592" rIns="109728" tIns="91440" bIns="73152">
+            <a:noAutofit/>
+          </a:bodyPr>
           <a:lstStyle/>
           <a:p>
             <a:pPr algn="ctr">
@@ -8663,8 +8683,8 @@
           <a:noFill/>
         </p:spPr>
         <p:txBody>
-          <a:bodyPr wrap="none" lIns="54864" rIns="54864" tIns="54864" bIns="54864" anchor="ctr">
-            <a:spAutoFit/>
+          <a:bodyPr wrap="square" lIns="54864" rIns="54864" tIns="54864" bIns="54864" anchor="ctr">
+            <a:noAutofit/>
           </a:bodyPr>
           <a:lstStyle/>
           <a:p>
@@ -8717,8 +8737,8 @@
           <a:noFill/>
         </p:spPr>
         <p:txBody>
-          <a:bodyPr wrap="none" lIns="54864" rIns="54864" tIns="54864" bIns="54864" anchor="ctr">
-            <a:spAutoFit/>
+          <a:bodyPr wrap="square" lIns="54864" rIns="54864" tIns="54864" bIns="54864" anchor="ctr">
+            <a:noAutofit/>
           </a:bodyPr>
           <a:lstStyle/>
           <a:p>
@@ -8753,8 +8773,8 @@
           <a:noFill/>
         </p:spPr>
         <p:txBody>
-          <a:bodyPr wrap="none" lIns="54864" rIns="54864" tIns="54864" bIns="54864" anchor="ctr">
-            <a:spAutoFit/>
+          <a:bodyPr wrap="square" lIns="54864" rIns="54864" tIns="54864" bIns="54864" anchor="ctr">
+            <a:noAutofit/>
           </a:bodyPr>
           <a:lstStyle/>
           <a:p>
@@ -9368,8 +9388,8 @@
           <a:noFill/>
         </p:spPr>
         <p:txBody>
-          <a:bodyPr wrap="none" lIns="54864" rIns="54864" tIns="54864" bIns="54864" anchor="ctr">
-            <a:spAutoFit/>
+          <a:bodyPr wrap="square" lIns="54864" rIns="54864" tIns="54864" bIns="54864" anchor="ctr">
+            <a:noAutofit/>
           </a:bodyPr>
           <a:lstStyle/>
           <a:p>
@@ -9422,8 +9442,8 @@
           <a:noFill/>
         </p:spPr>
         <p:txBody>
-          <a:bodyPr wrap="none" lIns="54864" rIns="54864" tIns="54864" bIns="54864" anchor="ctr">
-            <a:spAutoFit/>
+          <a:bodyPr wrap="square" lIns="54864" rIns="54864" tIns="54864" bIns="54864" anchor="ctr">
+            <a:noAutofit/>
           </a:bodyPr>
           <a:lstStyle/>
           <a:p>
@@ -9458,8 +9478,8 @@
           <a:noFill/>
         </p:spPr>
         <p:txBody>
-          <a:bodyPr wrap="none" lIns="54864" rIns="54864" tIns="54864" bIns="54864" anchor="ctr">
-            <a:spAutoFit/>
+          <a:bodyPr wrap="square" lIns="54864" rIns="54864" tIns="54864" bIns="54864" anchor="ctr">
+            <a:noAutofit/>
           </a:bodyPr>
           <a:lstStyle/>
           <a:p>
@@ -9952,8 +9972,8 @@
           <a:noFill/>
         </p:spPr>
         <p:txBody>
-          <a:bodyPr wrap="none" lIns="54864" rIns="54864" tIns="54864" bIns="54864" anchor="ctr">
-            <a:spAutoFit/>
+          <a:bodyPr wrap="square" lIns="54864" rIns="54864" tIns="54864" bIns="54864" anchor="ctr">
+            <a:noAutofit/>
           </a:bodyPr>
           <a:lstStyle/>
           <a:p>
@@ -10006,8 +10026,8 @@
           <a:noFill/>
         </p:spPr>
         <p:txBody>
-          <a:bodyPr wrap="none" lIns="54864" rIns="54864" tIns="54864" bIns="54864" anchor="ctr">
-            <a:spAutoFit/>
+          <a:bodyPr wrap="square" lIns="54864" rIns="54864" tIns="54864" bIns="54864" anchor="ctr">
+            <a:noAutofit/>
           </a:bodyPr>
           <a:lstStyle/>
           <a:p>
@@ -10042,8 +10062,8 @@
           <a:noFill/>
         </p:spPr>
         <p:txBody>
-          <a:bodyPr wrap="none" lIns="54864" rIns="54864" tIns="54864" bIns="54864" anchor="ctr">
-            <a:spAutoFit/>
+          <a:bodyPr wrap="square" lIns="54864" rIns="54864" tIns="54864" bIns="54864" anchor="ctr">
+            <a:noAutofit/>
           </a:bodyPr>
           <a:lstStyle/>
           <a:p>
@@ -10143,7 +10163,9 @@
           </a:fontRef>
         </p:style>
         <p:txBody>
-          <a:bodyPr rtlCol="0" anchor="ctr" lIns="164592" rIns="109728" tIns="91440" bIns="73152"/>
+          <a:bodyPr rtlCol="0" anchor="ctr" wrap="square" lIns="164592" rIns="109728" tIns="91440" bIns="73152">
+            <a:noAutofit/>
+          </a:bodyPr>
           <a:lstStyle/>
           <a:p>
             <a:pPr algn="ctr">
@@ -10255,7 +10277,9 @@
           </a:fontRef>
         </p:style>
         <p:txBody>
-          <a:bodyPr rtlCol="0" anchor="ctr" lIns="164592" rIns="109728" tIns="91440" bIns="73152"/>
+          <a:bodyPr rtlCol="0" anchor="ctr" wrap="square" lIns="164592" rIns="109728" tIns="91440" bIns="73152">
+            <a:noAutofit/>
+          </a:bodyPr>
           <a:lstStyle/>
           <a:p>
             <a:pPr algn="ctr">
@@ -10367,7 +10391,9 @@
           </a:fontRef>
         </p:style>
         <p:txBody>
-          <a:bodyPr rtlCol="0" anchor="ctr" lIns="164592" rIns="109728" tIns="91440" bIns="73152"/>
+          <a:bodyPr rtlCol="0" anchor="ctr" wrap="square" lIns="164592" rIns="109728" tIns="91440" bIns="73152">
+            <a:noAutofit/>
+          </a:bodyPr>
           <a:lstStyle/>
           <a:p>
             <a:pPr algn="ctr">
@@ -10479,7 +10505,9 @@
           </a:fontRef>
         </p:style>
         <p:txBody>
-          <a:bodyPr rtlCol="0" anchor="ctr" lIns="164592" rIns="109728" tIns="91440" bIns="73152"/>
+          <a:bodyPr rtlCol="0" anchor="ctr" wrap="square" lIns="164592" rIns="109728" tIns="91440" bIns="73152">
+            <a:noAutofit/>
+          </a:bodyPr>
           <a:lstStyle/>
           <a:p>
             <a:pPr algn="ctr">
@@ -10591,7 +10619,9 @@
           </a:fontRef>
         </p:style>
         <p:txBody>
-          <a:bodyPr rtlCol="0" anchor="ctr" lIns="164592" rIns="109728" tIns="91440" bIns="73152"/>
+          <a:bodyPr rtlCol="0" anchor="ctr" wrap="square" lIns="164592" rIns="109728" tIns="91440" bIns="73152">
+            <a:noAutofit/>
+          </a:bodyPr>
           <a:lstStyle/>
           <a:p>
             <a:pPr algn="ctr">
@@ -10703,7 +10733,9 @@
           </a:fontRef>
         </p:style>
         <p:txBody>
-          <a:bodyPr rtlCol="0" anchor="ctr" lIns="164592" rIns="109728" tIns="91440" bIns="73152"/>
+          <a:bodyPr rtlCol="0" anchor="ctr" wrap="square" lIns="164592" rIns="109728" tIns="91440" bIns="73152">
+            <a:noAutofit/>
+          </a:bodyPr>
           <a:lstStyle/>
           <a:p>
             <a:pPr algn="ctr">
@@ -10793,8 +10825,8 @@
           <a:noFill/>
         </p:spPr>
         <p:txBody>
-          <a:bodyPr wrap="none" lIns="54864" rIns="54864" tIns="54864" bIns="54864" anchor="ctr">
-            <a:spAutoFit/>
+          <a:bodyPr wrap="square" lIns="54864" rIns="54864" tIns="54864" bIns="54864" anchor="ctr">
+            <a:noAutofit/>
           </a:bodyPr>
           <a:lstStyle/>
           <a:p>

</xml_diff>